<commit_message>
Add missing link to repo
</commit_message>
<xml_diff>
--- a/Kopfuebung_Plugin_Praesentation.pptx
+++ b/Kopfuebung_Plugin_Praesentation.pptx
@@ -3615,7 +3615,7 @@
         <p:spPr>
           <a:xfrm>
             <a:off x="787400" y="4445000"/>
-            <a:ext cx="6731000" cy="1168400"/>
+            <a:ext cx="6731000" cy="1593722"/>
           </a:xfrm>
           <a:prstGeom prst="roundRect">
             <a:avLst/>
@@ -3669,7 +3669,7 @@
         <p:spPr>
           <a:xfrm>
             <a:off x="1092200" y="4737100"/>
-            <a:ext cx="6096000" cy="646331"/>
+            <a:ext cx="6096000" cy="1077218"/>
           </a:xfrm>
           <a:prstGeom prst="rect">
             <a:avLst/>
@@ -3704,6 +3704,14 @@
             </a:r>
           </a:p>
           <a:p>
+            <a:endParaRPr lang="de-DE" sz="1400" b="1" dirty="0">
+              <a:solidFill>
+                <a:srgbClr val="FFFFFF"/>
+              </a:solidFill>
+              <a:latin typeface="Aptos" panose="020B0004020202020204" pitchFamily="34" charset="0"/>
+            </a:endParaRPr>
+          </a:p>
+          <a:p>
             <a:r>
               <a:rPr lang="de-DE" sz="1400" b="1" dirty="0">
                 <a:solidFill>
@@ -3711,16 +3719,28 @@
                 </a:solidFill>
                 <a:latin typeface="Aptos" panose="020B0004020202020204" pitchFamily="34" charset="0"/>
               </a:rPr>
-              <a:t>Autor</a:t>
-            </a:r>
-            <a:r>
-              <a:rPr lang="de-DE" sz="1400" b="1">
+              <a:t>Autor: Yannic Kalka</a:t>
+            </a:r>
+          </a:p>
+          <a:p>
+            <a:r>
+              <a:rPr lang="de-DE" sz="1400" b="1" dirty="0">
                 <a:solidFill>
                   <a:srgbClr val="FFFFFF"/>
                 </a:solidFill>
                 <a:latin typeface="Aptos" panose="020B0004020202020204" pitchFamily="34" charset="0"/>
               </a:rPr>
-              <a:t>: Yannic Kalka</a:t>
+              <a:t>Verfügbar unter: </a:t>
+            </a:r>
+            <a:r>
+              <a:rPr lang="de-DE" sz="1400" b="1" dirty="0">
+                <a:solidFill>
+                  <a:srgbClr val="FFFFFF"/>
+                </a:solidFill>
+                <a:latin typeface="Aptos" panose="020B0004020202020204" pitchFamily="34" charset="0"/>
+                <a:hlinkClick r:id="rId2"/>
+              </a:rPr>
+              <a:t>https://github.com/kyannic52/moodle-mod_kopfuebung</a:t>
             </a:r>
             <a:endParaRPr lang="de-DE" sz="1400" b="1" dirty="0">
               <a:solidFill>

</xml_diff>

<commit_message>
Add plugin presentation as user guide
</commit_message>
<xml_diff>
--- a/Kopfuebung_Plugin_Praesentation.pptx
+++ b/Kopfuebung_Plugin_Praesentation.pptx
@@ -281,7 +281,7 @@
           <a:p>
             <a:fld id="{2B68D4A7-93F7-4FE8-BFE3-8B39EFF297C5}" type="datetimeFigureOut">
               <a:rPr lang="de-DE" smtClean="0"/>
-              <a:t>13.08.2026</a:t>
+              <a:t>14.08.2026</a:t>
             </a:fld>
             <a:endParaRPr lang="de-DE"/>
           </a:p>
@@ -479,7 +479,7 @@
           <a:p>
             <a:fld id="{2B68D4A7-93F7-4FE8-BFE3-8B39EFF297C5}" type="datetimeFigureOut">
               <a:rPr lang="de-DE" smtClean="0"/>
-              <a:t>13.08.2026</a:t>
+              <a:t>14.08.2026</a:t>
             </a:fld>
             <a:endParaRPr lang="de-DE"/>
           </a:p>
@@ -687,7 +687,7 @@
           <a:p>
             <a:fld id="{2B68D4A7-93F7-4FE8-BFE3-8B39EFF297C5}" type="datetimeFigureOut">
               <a:rPr lang="de-DE" smtClean="0"/>
-              <a:t>13.08.2026</a:t>
+              <a:t>14.08.2026</a:t>
             </a:fld>
             <a:endParaRPr lang="de-DE"/>
           </a:p>
@@ -885,7 +885,7 @@
           <a:p>
             <a:fld id="{2B68D4A7-93F7-4FE8-BFE3-8B39EFF297C5}" type="datetimeFigureOut">
               <a:rPr lang="de-DE" smtClean="0"/>
-              <a:t>13.08.2026</a:t>
+              <a:t>14.08.2026</a:t>
             </a:fld>
             <a:endParaRPr lang="de-DE"/>
           </a:p>
@@ -1160,7 +1160,7 @@
           <a:p>
             <a:fld id="{2B68D4A7-93F7-4FE8-BFE3-8B39EFF297C5}" type="datetimeFigureOut">
               <a:rPr lang="de-DE" smtClean="0"/>
-              <a:t>13.08.2026</a:t>
+              <a:t>14.08.2026</a:t>
             </a:fld>
             <a:endParaRPr lang="de-DE"/>
           </a:p>
@@ -1425,7 +1425,7 @@
           <a:p>
             <a:fld id="{2B68D4A7-93F7-4FE8-BFE3-8B39EFF297C5}" type="datetimeFigureOut">
               <a:rPr lang="de-DE" smtClean="0"/>
-              <a:t>13.08.2026</a:t>
+              <a:t>14.08.2026</a:t>
             </a:fld>
             <a:endParaRPr lang="de-DE"/>
           </a:p>
@@ -1837,7 +1837,7 @@
           <a:p>
             <a:fld id="{2B68D4A7-93F7-4FE8-BFE3-8B39EFF297C5}" type="datetimeFigureOut">
               <a:rPr lang="de-DE" smtClean="0"/>
-              <a:t>13.08.2026</a:t>
+              <a:t>14.08.2026</a:t>
             </a:fld>
             <a:endParaRPr lang="de-DE"/>
           </a:p>
@@ -1978,7 +1978,7 @@
           <a:p>
             <a:fld id="{2B68D4A7-93F7-4FE8-BFE3-8B39EFF297C5}" type="datetimeFigureOut">
               <a:rPr lang="de-DE" smtClean="0"/>
-              <a:t>13.08.2026</a:t>
+              <a:t>14.08.2026</a:t>
             </a:fld>
             <a:endParaRPr lang="de-DE"/>
           </a:p>
@@ -2091,7 +2091,7 @@
           <a:p>
             <a:fld id="{2B68D4A7-93F7-4FE8-BFE3-8B39EFF297C5}" type="datetimeFigureOut">
               <a:rPr lang="de-DE" smtClean="0"/>
-              <a:t>13.08.2026</a:t>
+              <a:t>14.08.2026</a:t>
             </a:fld>
             <a:endParaRPr lang="de-DE"/>
           </a:p>
@@ -2402,7 +2402,7 @@
           <a:p>
             <a:fld id="{2B68D4A7-93F7-4FE8-BFE3-8B39EFF297C5}" type="datetimeFigureOut">
               <a:rPr lang="de-DE" smtClean="0"/>
-              <a:t>13.08.2026</a:t>
+              <a:t>14.08.2026</a:t>
             </a:fld>
             <a:endParaRPr lang="de-DE"/>
           </a:p>
@@ -2690,7 +2690,7 @@
           <a:p>
             <a:fld id="{2B68D4A7-93F7-4FE8-BFE3-8B39EFF297C5}" type="datetimeFigureOut">
               <a:rPr lang="de-DE" smtClean="0"/>
-              <a:t>13.08.2026</a:t>
+              <a:t>14.08.2026</a:t>
             </a:fld>
             <a:endParaRPr lang="de-DE"/>
           </a:p>
@@ -2931,7 +2931,7 @@
           <a:p>
             <a:fld id="{2B68D4A7-93F7-4FE8-BFE3-8B39EFF297C5}" type="datetimeFigureOut">
               <a:rPr lang="de-DE" smtClean="0"/>
-              <a:t>13.08.2026</a:t>
+              <a:t>14.08.2026</a:t>
             </a:fld>
             <a:endParaRPr lang="de-DE"/>
           </a:p>
@@ -5718,27 +5718,45 @@
         <p:spPr>
           <a:xfrm>
             <a:off x="9169400" y="3492500"/>
-            <a:ext cx="2565400" cy="192360"/>
-          </a:xfrm>
-          <a:prstGeom prst="rect">
-            <a:avLst/>
-          </a:prstGeom>
-          <a:noFill/>
-        </p:spPr>
-        <p:txBody>
-          <a:bodyPr vert="horz" wrap="square" lIns="0" tIns="0" rIns="0" bIns="0" rtlCol="0">
-            <a:spAutoFit/>
-          </a:bodyPr>
-          <a:lstStyle/>
-          <a:p>
-            <a:r>
-              <a:rPr lang="de-DE" sz="1250">
+            <a:ext cx="2565400" cy="384721"/>
+          </a:xfrm>
+          <a:prstGeom prst="rect">
+            <a:avLst/>
+          </a:prstGeom>
+          <a:noFill/>
+        </p:spPr>
+        <p:txBody>
+          <a:bodyPr vert="horz" wrap="square" lIns="0" tIns="0" rIns="0" bIns="0" rtlCol="0">
+            <a:spAutoFit/>
+          </a:bodyPr>
+          <a:lstStyle/>
+          <a:p>
+            <a:r>
+              <a:rPr lang="de-DE" sz="1250" dirty="0">
                 <a:solidFill>
                   <a:srgbClr val="38312E"/>
                 </a:solidFill>
                 <a:latin typeface="Aptos" panose="020B0004020202020204" pitchFamily="34" charset="0"/>
               </a:rPr>
-              <a:t>•  Antwortfelder je Fragetyp</a:t>
+              <a:t>•  Alle Fragentypen möglich (inklusive Stack- und </a:t>
+            </a:r>
+            <a:r>
+              <a:rPr lang="de-DE" sz="1250" dirty="0" err="1">
+                <a:solidFill>
+                  <a:srgbClr val="38312E"/>
+                </a:solidFill>
+                <a:latin typeface="Aptos" panose="020B0004020202020204" pitchFamily="34" charset="0"/>
+              </a:rPr>
+              <a:t>Geogebra</a:t>
+            </a:r>
+            <a:r>
+              <a:rPr lang="de-DE" sz="1250" dirty="0">
+                <a:solidFill>
+                  <a:srgbClr val="38312E"/>
+                </a:solidFill>
+                <a:latin typeface="Aptos" panose="020B0004020202020204" pitchFamily="34" charset="0"/>
+              </a:rPr>
+              <a:t>-Aufgaben)</a:t>
             </a:r>
           </a:p>
         </p:txBody>
@@ -8514,7 +8532,7 @@
                 </a:solidFill>
                 <a:latin typeface="Aptos" panose="020B0004020202020204" pitchFamily="34" charset="0"/>
               </a:rPr>
-              <a:t>05 · ANALYSE · DETAIL LEHRPERSON</a:t>
+              <a:t>05 · ANALYSE · DETAIL LEHRKRAFT</a:t>
             </a:r>
           </a:p>
         </p:txBody>
@@ -8704,7 +8722,7 @@
         <p:spPr>
           <a:xfrm>
             <a:off x="9169400" y="1473200"/>
-            <a:ext cx="2565400" cy="923330"/>
+            <a:ext cx="2628900" cy="923330"/>
           </a:xfrm>
           <a:prstGeom prst="rect">
             <a:avLst/>
@@ -8724,7 +8742,7 @@
                 </a:solidFill>
                 <a:latin typeface="Aptos" panose="020B0004020202020204" pitchFamily="34" charset="0"/>
               </a:rPr>
-              <a:t>Eine Zelle lässt sich in </a:t>
+              <a:t>Eine Zelle der Übersicht lässt sich in </a:t>
             </a:r>
             <a:r>
               <a:rPr lang="de-DE" sz="1500" b="1" dirty="0" err="1">
@@ -8742,7 +8760,7 @@
                 </a:solidFill>
                 <a:latin typeface="Aptos" panose="020B0004020202020204" pitchFamily="34" charset="0"/>
               </a:rPr>
-              <a:t> für Lehrpersonen bis auf </a:t>
+              <a:t> für Lehrkraft bis auf </a:t>
             </a:r>
             <a:r>
               <a:rPr lang="de-DE" sz="1500" b="1" dirty="0" err="1">
@@ -9382,7 +9400,7 @@
         <p:spPr>
           <a:xfrm>
             <a:off x="889000" y="2832100"/>
-            <a:ext cx="2946400" cy="400110"/>
+            <a:ext cx="2946400" cy="600164"/>
           </a:xfrm>
           <a:prstGeom prst="rect">
             <a:avLst/>
@@ -9402,7 +9420,7 @@
                 </a:solidFill>
                 <a:latin typeface="Aptos" panose="020B0004020202020204" pitchFamily="34" charset="0"/>
               </a:rPr>
-              <a:t>Lehrkraft startet und stoppt zentral. Zeitablauf schließt automatisch.</a:t>
+              <a:t>Lehrkraft startet und stoppt Kopfübung zentral. Zeitablauf schließt Versuche automatisch.</a:t>
             </a:r>
           </a:p>
         </p:txBody>
@@ -9960,13 +9978,13 @@
           <a:lstStyle/>
           <a:p>
             <a:r>
-              <a:rPr lang="de-DE" sz="1300">
+              <a:rPr lang="de-DE" sz="1300" dirty="0">
                 <a:solidFill>
                   <a:srgbClr val="837B77"/>
                 </a:solidFill>
                 <a:latin typeface="Aptos" panose="020B0004020202020204" pitchFamily="34" charset="0"/>
               </a:rPr>
-              <a:t>Einzel- und Klassenmatrix, Detailansichten und Versuchsnachbesprechung.</a:t>
+              <a:t>Ergebnisse in Einzel- und Klassenmatrix, Detailansichten und Versuchsnachbesprechung.</a:t>
             </a:r>
           </a:p>
         </p:txBody>
@@ -10520,7 +10538,7 @@
                 </a:solidFill>
                 <a:latin typeface="Aptos" panose="020B0004020202020204" pitchFamily="34" charset="0"/>
               </a:rPr>
-              <a:t>05 · ANALYSE · DETAIL LEHRPERSON</a:t>
+              <a:t>05 · ANALYSE · DETAIL LEHRKRAFT</a:t>
             </a:r>
           </a:p>
         </p:txBody>
@@ -10788,7 +10806,7 @@
                 </a:solidFill>
                 <a:latin typeface="Aptos" panose="020B0004020202020204" pitchFamily="34" charset="0"/>
               </a:rPr>
-              <a:t> als auch Lehrpersonen zur Analyse einsehbar</a:t>
+              <a:t> als auch Lehrkräfte zur Analyse einsehbar</a:t>
             </a:r>
           </a:p>
         </p:txBody>
@@ -11064,7 +11082,7 @@
                 </a:solidFill>
                 <a:latin typeface="Aptos" panose="020B0004020202020204" pitchFamily="34" charset="0"/>
               </a:rPr>
-              <a:t>06 · FÖRDERUNG · LEHRPERSON</a:t>
+              <a:t>06 · FÖRDERUNG · LEHRKRAFT</a:t>
             </a:r>
           </a:p>
         </p:txBody>
@@ -11927,7 +11945,7 @@
         <p:spPr>
           <a:xfrm>
             <a:off x="9169400" y="4406900"/>
-            <a:ext cx="2565400" cy="192360"/>
+            <a:ext cx="2565400" cy="961802"/>
           </a:xfrm>
           <a:prstGeom prst="rect">
             <a:avLst/>
@@ -11947,7 +11965,42 @@
                 </a:solidFill>
                 <a:latin typeface="Aptos" panose="020B0004020202020204" pitchFamily="34" charset="0"/>
               </a:rPr>
-              <a:t>•  Direkter Rückweg zur Übersicht</a:t>
+              <a:t>•  In diesem Fall hat die Lehrkraft individuell der </a:t>
+            </a:r>
+            <a:r>
+              <a:rPr lang="de-DE" sz="1250" dirty="0" err="1">
+                <a:solidFill>
+                  <a:srgbClr val="38312E"/>
+                </a:solidFill>
+                <a:latin typeface="Aptos" panose="020B0004020202020204" pitchFamily="34" charset="0"/>
+              </a:rPr>
+              <a:t>Schüler:in</a:t>
+            </a:r>
+            <a:r>
+              <a:rPr lang="de-DE" sz="1250" dirty="0">
+                <a:solidFill>
+                  <a:srgbClr val="38312E"/>
+                </a:solidFill>
+                <a:latin typeface="Aptos" panose="020B0004020202020204" pitchFamily="34" charset="0"/>
+              </a:rPr>
+              <a:t> das Zusatzangebot zugewiesen</a:t>
+            </a:r>
+            <a:br>
+              <a:rPr lang="de-DE" sz="1250" dirty="0">
+                <a:solidFill>
+                  <a:srgbClr val="38312E"/>
+                </a:solidFill>
+                <a:latin typeface="Aptos" panose="020B0004020202020204" pitchFamily="34" charset="0"/>
+              </a:rPr>
+            </a:br>
+            <a:r>
+              <a:rPr lang="de-DE" sz="1250" dirty="0">
+                <a:solidFill>
+                  <a:srgbClr val="38312E"/>
+                </a:solidFill>
+                <a:latin typeface="Aptos" panose="020B0004020202020204" pitchFamily="34" charset="0"/>
+              </a:rPr>
+              <a:t>(nächste Folie Ansicht regelbasierte Zuweisung)</a:t>
             </a:r>
           </a:p>
         </p:txBody>
@@ -14164,7 +14217,7 @@
                 </a:solidFill>
                 <a:latin typeface="Aptos" panose="020B0004020202020204" pitchFamily="34" charset="0"/>
               </a:rPr>
-              <a:t>•  Bereitschaft und Feedback können optional gesteuert werden</a:t>
+              <a:t>•  Bereitschaft und Feedback können optional ausgewählt werden</a:t>
             </a:r>
           </a:p>
         </p:txBody>
@@ -15000,27 +15053,27 @@
         <p:spPr>
           <a:xfrm>
             <a:off x="9169400" y="1473200"/>
-            <a:ext cx="2565400" cy="692497"/>
-          </a:xfrm>
-          <a:prstGeom prst="rect">
-            <a:avLst/>
-          </a:prstGeom>
-          <a:noFill/>
-        </p:spPr>
-        <p:txBody>
-          <a:bodyPr vert="horz" wrap="square" lIns="0" tIns="0" rIns="0" bIns="0" rtlCol="0">
-            <a:spAutoFit/>
-          </a:bodyPr>
-          <a:lstStyle/>
-          <a:p>
-            <a:r>
-              <a:rPr lang="de-DE" sz="1500" b="1">
+            <a:ext cx="2565400" cy="461665"/>
+          </a:xfrm>
+          <a:prstGeom prst="rect">
+            <a:avLst/>
+          </a:prstGeom>
+          <a:noFill/>
+        </p:spPr>
+        <p:txBody>
+          <a:bodyPr vert="horz" wrap="square" lIns="0" tIns="0" rIns="0" bIns="0" rtlCol="0">
+            <a:spAutoFit/>
+          </a:bodyPr>
+          <a:lstStyle/>
+          <a:p>
+            <a:r>
+              <a:rPr lang="de-DE" sz="1500" b="1" dirty="0">
                 <a:solidFill>
                   <a:srgbClr val="182844"/>
                 </a:solidFill>
                 <a:latin typeface="Aptos" panose="020B0004020202020204" pitchFamily="34" charset="0"/>
               </a:rPr>
-              <a:t>Der Start bleibt vollständig unter Kontrolle der Lehrperson.</a:t>
+              <a:t>Der Start bleibt vollständig unter Kontrolle der Lehrkraft.</a:t>
             </a:r>
           </a:p>
         </p:txBody>
@@ -15492,7 +15545,7 @@
                 </a:solidFill>
                 <a:latin typeface="Aptos" panose="020B0004020202020204" pitchFamily="34" charset="0"/>
               </a:rPr>
-              <a:t>Wenn alle Kategorien mit Fragen zugewiesen sind ist das Starten der Kopfübung möglich.</a:t>
+              <a:t>Wenn alle Aufgaben mit Fragen zugewiesen sind ist das Starten der Kopfübung möglich.</a:t>
             </a:r>
           </a:p>
         </p:txBody>
@@ -15802,13 +15855,22 @@
           <a:lstStyle/>
           <a:p>
             <a:r>
-              <a:rPr lang="de-DE" sz="2700" b="1">
+              <a:rPr lang="de-DE" sz="2700" b="1" dirty="0" err="1">
                 <a:solidFill>
                   <a:srgbClr val="182844"/>
                 </a:solidFill>
                 <a:latin typeface="Aptos" panose="020B0004020202020204" pitchFamily="34" charset="0"/>
               </a:rPr>
-              <a:t>Schüler:innenansicht: bereit melden</a:t>
+              <a:t>Schüler:innenansicht</a:t>
+            </a:r>
+            <a:r>
+              <a:rPr lang="de-DE" sz="2700" b="1" dirty="0">
+                <a:solidFill>
+                  <a:srgbClr val="182844"/>
+                </a:solidFill>
+                <a:latin typeface="Aptos" panose="020B0004020202020204" pitchFamily="34" charset="0"/>
+              </a:rPr>
+              <a:t>: Bereit melden</a:t>
             </a:r>
           </a:p>
         </p:txBody>
@@ -16325,7 +16387,7 @@
                 </a:solidFill>
                 <a:latin typeface="Aptos" panose="020B0004020202020204" pitchFamily="34" charset="0"/>
               </a:rPr>
-              <a:t>: bereit und warten</a:t>
+              <a:t>: Bereit und warten</a:t>
             </a:r>
           </a:p>
         </p:txBody>

</xml_diff>